<commit_message>
Some changes made and some functions have been added to project
</commit_message>
<xml_diff>
--- a/docs/BenelaAI Investor Pitch .pptx
+++ b/docs/BenelaAI Investor Pitch .pptx
@@ -2054,11 +2054,22 @@
                 <a:solidFill>
                   <a:srgbClr val="F0F0F5"/>
                 </a:solidFill>
-                <a:latin typeface="Calibri" pitchFamily="34" charset="0"/>
-                <a:ea typeface="Calibri" pitchFamily="34" charset="-122"/>
-                <a:cs typeface="Calibri" pitchFamily="34" charset="-120"/>
-              </a:rPr>
-              <a:t>BENELA AI</a:t>
+                <a:latin typeface="SF Pro Heavy" pitchFamily="2" charset="0"/>
+                <a:ea typeface="SF Pro Heavy" pitchFamily="2" charset="0"/>
+                <a:cs typeface="SF Pro Heavy" pitchFamily="2" charset="0"/>
+              </a:rPr>
+              <a:t>BENELA</a:t>
+            </a:r>
+            <a:r>
+              <a:rPr lang="en-US" sz="5200" b="1" kern="0" spc="800" dirty="0">
+                <a:solidFill>
+                  <a:srgbClr val="F0F0F5"/>
+                </a:solidFill>
+                <a:latin typeface="Calibri" pitchFamily="34" charset="0"/>
+                <a:ea typeface="Calibri" pitchFamily="34" charset="-122"/>
+                <a:cs typeface="Calibri" pitchFamily="34" charset="-120"/>
+              </a:rPr>
+              <a:t> AI</a:t>
             </a:r>
             <a:endParaRPr lang="en-US" sz="5200" dirty="0"/>
           </a:p>

</xml_diff>